<commit_message>
Fix the broken full walkthrough, add an inline-script parse guard, and settle five open questions against their documents (v26.6.238)
- walkthrough/full.html threw a SyntaxError (unescaped apostrophe in the slogan) and rendered no slides; fixed, and scripts/check-inline-js.mjs now parses every inline script in CI
- odd-even: state the working paper's 13% (press summaries gave 14 to 16%)
- NCAP: show the Lok Sabha reply's Rs 10,003 crore beside CREA's Rs 9,929 crore; correct Delhi's Rs 81 crore from allocated to released
- Delhi 2026 targets: cuts are measured against the five-year average (HT, TOI); table rebuilt with 2024, 2025 and goal levels
- Hindi, Tamil, Marathi and Bengali strings follow the rewritten English
- regenerate the how-it-works diagram without em dashes and re-export the walkthrough PDFs and PPTX files

Co-Authored-By: Claude Sonnet 5.5 <noreply@anthropic.com>
Claude-Session: https://claude.ai/code/session_012rAasScscctovhuAo1Lxr1
</commit_message>
<xml_diff>
--- a/walkthrough/JanVayu_Full_Walkthrough.pptx
+++ b/walkthrough/JanVayu_Full_Walkthrough.pptx
@@ -45,6 +45,7 @@
     <p:sldId id="293" r:id="rId45"/>
     <p:sldId id="294" r:id="rId46"/>
     <p:sldId id="295" r:id="rId47"/>
+    <p:sldId id="296" r:id="rId48"/>
   </p:sldIdLst>
   <p:sldSz cx="12192000" cy="6858000" type="screen4x3"/>
   <p:notesSz cx="6858000" cy="9144000"/>
@@ -681,7 +682,7 @@
           <a:lstStyle/>
           <a:p>
             <a:r>
-              <a:t>The forecast is key-less and free; it feeds the chatbot’s tomorrow-answers too. Be honest about the fire map’s season — it peaks mid-Oct to late-Nov and is quiet the rest of the year.</a:t>
+              <a:t>The forecast is key-less and free; it feeds the chatbot’s tomorrow-answers too. Say plainly that the fire map is seasonal: the burning season it is built around runs from October into November.</a:t>
             </a:r>
           </a:p>
         </p:txBody>
@@ -751,7 +752,7 @@
           <a:lstStyle/>
           <a:p>
             <a:r>
-              <a:t>The old version was a dropdown of 142 cities — if your town was not on the list you got nothing. That was our database structure leaking into the navigation. Say the two timescales out loud: the dots are live monitors, the shading is a yearly satellite average, and they are never the same sentence. The green-vs-tree distinction is the one to demo: green counts cropland, so the typical Indian district is 97% green and 14% treed.</a:t>
+              <a:t>The old version was a dropdown of 142 cities, and if your town was not on the list you got nothing. That was our database structure leaking into the navigation. Say the two timescales out loud: the dots are live monitors, the shading is a yearly satellite average, and they are never the same sentence. The green-vs-tree distinction is the one to demo: green counts cropland, so the typical Indian district is 97% green and 14% treed.</a:t>
             </a:r>
           </a:p>
         </p:txBody>
@@ -821,7 +822,7 @@
           <a:lstStyle/>
           <a:p>
             <a:r>
-              <a:t>The point of this slide is the monitoring gap: ~565 continuous CPCB stations against 584,615 villages, so the live network can never answer "how is my village's air". Satellite fills it on a DIFFERENT timescale — annual, not today. Keep the two apart out loud. Two honest caveats: a ~1 km product smooths hyperlocal sources (a kiln next door won't show), and it is modelled and calibrated, not measured in the village. The finding worth saying: not one Indian village meets the WHO guideline of 5, and 63.6% are above India's own limit of 40.</a:t>
+              <a:t>The point of this slide is the monitoring gap: ~565 continuous CPCB stations against 584,615 villages, so the live network can never answer "how is my village's air". Satellite fills it on a DIFFERENT timescale: annual, not today. Keep the two apart out loud. Two honest caveats: a ~1 km product smooths hyperlocal sources (a kiln next door won't show), and it is modelled and calibrated, not measured in the village. The finding worth saying: not one Indian village meets the WHO guideline of 5, and 63.6% are above India's own limit of 40.</a:t>
             </a:r>
           </a:p>
         </p:txBody>
@@ -891,7 +892,7 @@
           <a:lstStyle/>
           <a:p>
             <a:r>
-              <a:t>This slide is the one negative result worth presenting. It came out of testing two global land-pressure rasters that correlated better with district PM2.5 than anything on the site, then collapsing under state fixed effects. What survived was the decomposition: where you are in India decides most of your air, and the town you live in decides the rest. Say the limit out loud, because it is the part people over-read — a district below its state median is NOT thereby well governed, and the figure names no cause at all. The history layer under it is LongPMInd (Wei et al. 2024, peer-reviewed, ~10 km, CC BY 4.0) and it is a RECONSTRUCTION: India had almost no continuous monitoring before the 2010s. It is not differenceable against the 2024 satellite layer — trend and shape from the history, level from the annual. Delhi as a whole goes 50.9 in the 1980s to 91.6 over 2013-2022, which independently reproduces Hawa Ka Hisab’s published figures by a different method.</a:t>
+              <a:t>This slide is the one negative result worth presenting. It came out of testing two global land-pressure rasters that correlated better with district PM2.5 than anything on the site, then collapsing under state fixed effects. What survived was the decomposition: where you are in India decides most of your air, and the town you live in decides the rest. Say the limit out loud, because it is the part people over-read: a district below its state median is NOT thereby well governed, and the figure names no cause at all. The history layer under it is LongPMInd (Wang et al. 2024, peer-reviewed, ~10 km, CC BY 4.0) and it is a RECONSTRUCTION: India had almost no continuous monitoring before the 2010s. It is not directly comparable with the 2024 satellite layer. Take the trend and shape from the history and the level from the annual figure. Delhi as a whole goes 50.9 in the 1980s to 91.6 over 2013-2022, which agrees with the decade means in Hawa Ka Hisab’s report (51 for the 1980s, 87 for the 2010s); that report is built on the same LongPMInd data, so this is a consistency check, not an independent reproduction.</a:t>
             </a:r>
           </a:p>
         </p:txBody>
@@ -961,7 +962,7 @@
           <a:lstStyle/>
           <a:p>
             <a:r>
-              <a:t>Push is real VAPID web push; alerts are gated on a user-picked threshold. Both the main site and the standalone Ask JanVayu app install as PWAs on Android, iOS and desktop.</a:t>
+              <a:t>These are real browser push notifications, sent only when your city crosses the threshold you picked. Both the main site and the standalone Ask JanVayu app can be installed on Android, iOS and desktop.</a:t>
             </a:r>
           </a:p>
         </p:txBody>
@@ -1031,7 +1032,7 @@
           <a:lstStyle/>
           <a:p>
             <a:r>
-              <a:t>Chapter 3 — Health &amp; exposure. Translate the numbers into what they mean for a body.</a:t>
+              <a:t>Chapter 3: Health &amp; exposure. Translate the numbers into what they mean for a body.</a:t>
             </a:r>
           </a:p>
         </p:txBody>
@@ -1311,7 +1312,7 @@
           <a:lstStyle/>
           <a:p>
             <a:r>
-              <a:t>Chapter 1 — Why it exists. Set the stakes and the stance before touching the product.</a:t>
+              <a:t>Chapter 1: Why it exists. Set the stakes and the stance before touching the product.</a:t>
             </a:r>
           </a:p>
         </p:txBody>
@@ -1451,7 +1452,7 @@
           <a:lstStyle/>
           <a:p>
             <a:r>
-              <a:t>Chapter 4 — The economic bill. The macroeconomic case, for policy audiences.</a:t>
+              <a:t>Chapter 4: The economic bill. The macroeconomic case, for policy audiences.</a:t>
             </a:r>
           </a:p>
         </p:txBody>
@@ -1591,7 +1592,7 @@
           <a:lstStyle/>
           <a:p>
             <a:r>
-              <a:t>Chapter 5 — Following the money. Accountability — the differentiator versus a plain dashboard.</a:t>
+              <a:t>Chapter 5: Following the money. Accountability, which is what sets JanVayu apart from a plain dashboard.</a:t>
             </a:r>
           </a:p>
         </p:txBody>
@@ -1941,7 +1942,7 @@
           <a:lstStyle/>
           <a:p>
             <a:r>
-              <a:t>Chapter 6 — Citizen action. Turn readers into participants.</a:t>
+              <a:t>Chapter 6: Citizen action. Turn readers into participants.</a:t>
             </a:r>
           </a:p>
         </p:txBody>
@@ -2011,7 +2012,7 @@
           <a:lstStyle/>
           <a:p>
             <a:r>
-              <a:t>Games + the new air-literacy quiz make this classroom-ready; workshops connect to a live facilitator.</a:t>
+              <a:t>Games + the new air-literacy quiz make this classroom-ready; workshops connect you to a live session leader.</a:t>
             </a:r>
           </a:p>
         </p:txBody>
@@ -2151,7 +2152,7 @@
           <a:lstStyle/>
           <a:p>
             <a:r>
-              <a:t>If someone asks why X and Instagram are only links: neither can be read without a paid or authenticated API, so we link to the live search rather than show a feed that is not one — and every X link on the site is checked against X’s public embed endpoint before it ships. The blog section is generated from the blog index, so publishing is enough to reach the front page. Every gallery photograph carries its own credit and source link.</a:t>
+              <a:t>If someone asks why X and Instagram are only links: neither can be read without a paid or authenticated API, so we link to the live search rather than show a feed that is not one. Every X link on the site is checked against X’s public embed endpoint before it ships. The blog section is generated from the blog index, so publishing is enough to reach the front page. Every gallery photograph carries its own credit and source link.</a:t>
             </a:r>
           </a:p>
         </p:txBody>
@@ -2221,7 +2222,7 @@
           <a:lstStyle/>
           <a:p>
             <a:r>
-              <a:t>Chapter 7 — Tools &amp; knowledge. The reference layer and the take-it-with-you surfaces.</a:t>
+              <a:t>Chapter 7: Tools &amp; knowledge. The reference layer and the take-it-with-you surfaces.</a:t>
             </a:r>
           </a:p>
         </p:txBody>
@@ -2291,7 +2292,7 @@
           <a:lstStyle/>
           <a:p>
             <a:r>
-              <a:t>It answers from JanVayu’s own verified figures and cites them; an eval suite gates it against fabricated citations and invented orders or schemes.</a:t>
+              <a:t>It answers from JanVayu’s own verified figures and cites them. It is tested against fabricated citations and invented orders or schemes before each release.</a:t>
             </a:r>
           </a:p>
         </p:txBody>
@@ -2501,7 +2502,7 @@
           <a:lstStyle/>
           <a:p>
             <a:r>
-              <a:t>Chapter 8 — Trust. Close the loop on why any of these numbers can be believed.</a:t>
+              <a:t>Chapter 8: Trust. Close the loop on why any of these numbers can be believed.</a:t>
             </a:r>
           </a:p>
         </p:txBody>
@@ -2571,7 +2572,7 @@
           <a:lstStyle/>
           <a:p>
             <a:r>
-              <a:t>This is what separates JanVayu from a marketing site, and it is worth being exact about which half is continuous and which is periodic. Continuous: the build recomputes every stated figure from the underlying data and fails on drift, and since September 2026 it also refuses a claim the site has publicly retracted, including inside the Hindi, Bengali, Marathi and Tamil docs. Periodic: a deeper audit that re-verifies statistics against primary sources on the web, whose findings are written into dated files in docs/. That deeper audit ran weekly through July 2026 and the deck used to promise weekly; it is not on a schedule now, so the wording says periodic. A guard fails the build if it goes more than four months without running.</a:t>
+              <a:t>This is what separates JanVayu from a marketing site, and it is worth being exact about which half is continuous and which is periodic. Continuous: every stated figure is recomputed from the underlying data whenever the site changes, a mismatch stops the release, and since September 2026 a claim the site has publicly retracted is refused too, including inside the Hindi, Bengali, Marathi and Tamil docs. Periodic: a deeper audit that re-verifies statistics against primary sources on the web, whose findings are written into dated files in docs/. That deeper audit ran weekly through July 2026 and the deck used to promise weekly; it is not on a schedule now, so the wording says periodic. The release is stopped automatically if the audit goes more than four months without running.</a:t>
             </a:r>
           </a:p>
         </p:txBody>
@@ -2641,7 +2642,7 @@
           <a:lstStyle/>
           <a:p>
             <a:r>
-              <a:t>This is the slide that answers "how do you know your map is right". Be careful not to oversell it: the comparison validates pattern, not level, and a point monitor is not a district mean. Two honest by-products worth mentioning. First, 250 of 534 stations cannot produce a defensible annual mean for 2024 — they fail a twelve-month completeness test — which is a finding about the monitoring network, not a filter we should loosen. Second, the archive advertises coverage to March 2026 but CPCB’s feed into it stops on 1 September 2025; the months after are two US Embassy monitors. We documented that the day after we got it wrong ourselves.</a:t>
+              <a:t>This is the slide that answers "how do you know your map is right". Be careful not to oversell it: the comparison validates pattern, not level, and a point monitor is not a district mean. Two honest by-products worth mentioning. First, 250 of 534 stations cannot produce a defensible annual mean for 2024. They fail a twelve-month completeness test, which is a finding about the monitoring network, not a filter we should loosen. Second, the archive advertises coverage to March 2026 but CPCB’s feed into it stops on 1 September 2025; the months after are two US Embassy monitors. We documented that the day after we got it wrong ourselves.</a:t>
             </a:r>
           </a:p>
         </p:txBody>
@@ -2711,7 +2712,7 @@
           <a:lstStyle/>
           <a:p>
             <a:r>
-              <a:t>The most quotable slide in the deck, so be precise about what it does and does not show. It removes weather as an explanation; it does not prove policy caused the rest. Emissions, fuel mix, construction and economic activity all sit inside what is left. Worth adding that normalisation mostly confirms the raw trend — only 6 of 44 cities move by a microgram a year or more — and in five of those the raw number was understating the improvement, so the fear that a city is claiming credit the wind earned is rarer than people expect. R² runs 0.52 to 0.91; cities are not comparable to each other on it.</a:t>
+              <a:t>Two things to be careful about if asked. First, there is deliberately no trend line across the window and the build refuses to let one in: reporting grew from 10 cities in 2015 to 264 in 2024 and the stations under each city grew with it, so a fall in Poor-or-worse days cannot be separated from a change in what was measuring. Read a single year. Second, 2015 and 2026 are part years and are marked as such next to the number, because 136 bad days of 235 in 2015 against 157 of 366 in 2024 reads as a rise and is a fall. 2015–2025 is UrbanEmissions.info’s extraction, credited on the panel; 2026 is our own parse of the same PDFs, and on three 2025 dates checked city by city the two agree on all 671 city-days they share.</a:t>
             </a:r>
           </a:p>
         </p:txBody>
@@ -2781,7 +2782,7 @@
           <a:lstStyle/>
           <a:p>
             <a:r>
-              <a:t>The live-vs-annual honesty is a recurring theme; it protects the platform from over-claiming.</a:t>
+              <a:t>The most quotable slide in the deck, so be precise about what it does and does not show. It removes weather as an explanation; it does not prove policy caused the rest. Emissions, fuel mix, construction and economic activity all sit inside what is left. Worth adding that normalisation mostly confirms the raw trend: only 6 of 44 cities move by a microgram a year or more, and in four of those the raw number understated the improvement, while in two (Agra, Pune) it overstated it, so the fear that a city is claiming credit the wind earned is rarer than people expect. R² runs 0.52 to 0.91; cities are not comparable to each other on it.</a:t>
             </a:r>
           </a:p>
         </p:txBody>
@@ -2921,7 +2922,7 @@
           <a:lstStyle/>
           <a:p>
             <a:r>
-              <a:t>Close on agency: the point of all this data is to be used. Point to the API, the RTI Assistant, and contribute@janvayu.in.</a:t>
+              <a:t>The live-vs-annual honesty is a recurring theme; it protects the platform from over-claiming.</a:t>
             </a:r>
           </a:p>
         </p:txBody>
@@ -2946,7 +2947,7 @@
 </p:notes>
 </file>
 
-<file path=ppt/notesSlides/notesSlide5.xml><?xml version="1.0" encoding="utf-8"?>
+<file path=ppt/notesSlides/notesSlide41.xml><?xml version="1.0" encoding="utf-8"?>
 <p:notes xmlns:a="http://schemas.openxmlformats.org/drawingml/2006/main" xmlns:p="http://schemas.openxmlformats.org/presentationml/2006/main" xmlns:r="http://schemas.openxmlformats.org/officeDocument/2006/relationships">
   <p:cSld>
     <p:spTree>
@@ -2991,7 +2992,7 @@
           <a:lstStyle/>
           <a:p>
             <a:r>
-              <a:t>The value-add is synthesis and honesty, not owning sensors. Name the sources so users can verify.</a:t>
+              <a:t>Close on agency: the point of all this data is to be used. Point to the API, the RTI Assistant, and contribute@janvayu.in.</a:t>
             </a:r>
           </a:p>
         </p:txBody>
@@ -3016,7 +3017,7 @@
 </p:notes>
 </file>
 
-<file path=ppt/notesSlides/notesSlide6.xml><?xml version="1.0" encoding="utf-8"?>
+<file path=ppt/notesSlides/notesSlide5.xml><?xml version="1.0" encoding="utf-8"?>
 <p:notes xmlns:a="http://schemas.openxmlformats.org/drawingml/2006/main" xmlns:p="http://schemas.openxmlformats.org/presentationml/2006/main" xmlns:r="http://schemas.openxmlformats.org/officeDocument/2006/relationships">
   <p:cSld>
     <p:spTree>
@@ -3061,7 +3062,7 @@
           <a:lstStyle/>
           <a:p>
             <a:r>
-              <a:t>Chapter 2 — The live picture. The real-time surfaces — the parts people check daily.</a:t>
+              <a:t>The value-add is synthesis and honesty, not owning sensors. Name the sources so users can verify.</a:t>
             </a:r>
           </a:p>
         </p:txBody>
@@ -3086,7 +3087,7 @@
 </p:notes>
 </file>
 
-<file path=ppt/notesSlides/notesSlide7.xml><?xml version="1.0" encoding="utf-8"?>
+<file path=ppt/notesSlides/notesSlide6.xml><?xml version="1.0" encoding="utf-8"?>
 <p:notes xmlns:a="http://schemas.openxmlformats.org/drawingml/2006/main" xmlns:p="http://schemas.openxmlformats.org/presentationml/2006/main" xmlns:r="http://schemas.openxmlformats.org/officeDocument/2006/relationships">
   <p:cSld>
     <p:spTree>
@@ -3131,7 +3132,7 @@
           <a:lstStyle/>
           <a:p>
             <a:r>
-              <a:t>Walk the dashboard top to bottom; point out the city selector drives the whole page.</a:t>
+              <a:t>Chapter 2: The live picture. The real-time panels, the ones people check daily.</a:t>
             </a:r>
           </a:p>
         </p:txBody>
@@ -3156,7 +3157,7 @@
 </p:notes>
 </file>
 
-<file path=ppt/notesSlides/notesSlide8.xml><?xml version="1.0" encoding="utf-8"?>
+<file path=ppt/notesSlides/notesSlide7.xml><?xml version="1.0" encoding="utf-8"?>
 <p:notes xmlns:a="http://schemas.openxmlformats.org/drawingml/2006/main" xmlns:p="http://schemas.openxmlformats.org/presentationml/2006/main" xmlns:r="http://schemas.openxmlformats.org/officeDocument/2006/relationships">
   <p:cSld>
     <p:spTree>
@@ -3201,7 +3202,77 @@
           <a:lstStyle/>
           <a:p>
             <a:r>
-              <a:t>Core cities load live; the rest load when picked, to stay inside the data source’s free tier — but that’s a build detail, not something the reader needs on screen.</a:t>
+              <a:t>Walk the dashboard top to bottom; point out the city selector drives the whole page.</a:t>
+            </a:r>
+          </a:p>
+        </p:txBody>
+      </p:sp>
+      <p:sp>
+        <p:nvSpPr>
+          <p:cNvPr id="4" name="Slide Number Placeholder 3"/>
+          <p:cNvSpPr>
+            <a:spLocks noGrp="1"/>
+          </p:cNvSpPr>
+          <p:nvPr>
+            <p:ph type="sldNum" idx="5" sz="quarter"/>
+          </p:nvPr>
+        </p:nvSpPr>
+        <p:spPr/>
+      </p:sp>
+    </p:spTree>
+  </p:cSld>
+  <p:clrMapOvr>
+    <a:masterClrMapping/>
+  </p:clrMapOvr>
+</p:notes>
+</file>
+
+<file path=ppt/notesSlides/notesSlide8.xml><?xml version="1.0" encoding="utf-8"?>
+<p:notes xmlns:a="http://schemas.openxmlformats.org/drawingml/2006/main" xmlns:p="http://schemas.openxmlformats.org/presentationml/2006/main" xmlns:r="http://schemas.openxmlformats.org/officeDocument/2006/relationships">
+  <p:cSld>
+    <p:spTree>
+      <p:nvGrpSpPr>
+        <p:cNvPr id="1" name=""/>
+        <p:cNvGrpSpPr/>
+        <p:nvPr/>
+      </p:nvGrpSpPr>
+      <p:grpSpPr>
+        <a:xfrm>
+          <a:off x="0" y="0"/>
+          <a:ext cx="0" cy="0"/>
+          <a:chOff x="0" y="0"/>
+          <a:chExt cx="0" cy="0"/>
+        </a:xfrm>
+      </p:grpSpPr>
+      <p:sp>
+        <p:nvSpPr>
+          <p:cNvPr id="2" name="Slide Image Placeholder 1"/>
+          <p:cNvSpPr>
+            <a:spLocks noGrp="1"/>
+          </p:cNvSpPr>
+          <p:nvPr>
+            <p:ph type="sldImg" idx="2"/>
+          </p:nvPr>
+        </p:nvSpPr>
+        <p:spPr/>
+      </p:sp>
+      <p:sp>
+        <p:nvSpPr>
+          <p:cNvPr id="3" name="Notes Placeholder 2"/>
+          <p:cNvSpPr>
+            <a:spLocks noGrp="1"/>
+          </p:cNvSpPr>
+          <p:nvPr>
+            <p:ph type="body" idx="3" sz="quarter"/>
+          </p:nvPr>
+        </p:nvSpPr>
+        <p:spPr/>
+        <p:txBody>
+          <a:bodyPr/>
+          <a:lstStyle/>
+          <a:p>
+            <a:r>
+              <a:t>Core cities load live; the rest load when picked, to stay inside the data source’s free tier.</a:t>
             </a:r>
           </a:p>
         </p:txBody>
@@ -7708,6 +7779,48 @@
       <p:pic>
         <p:nvPicPr>
           <p:cNvPr id="2" name="Picture 1" descr="slide-40.jpg"/>
+          <p:cNvPicPr>
+            <a:picLocks noChangeAspect="1"/>
+          </p:cNvPicPr>
+          <p:nvPr/>
+        </p:nvPicPr>
+        <p:blipFill>
+          <a:blip r:embed="rId2"/>
+          <a:stretch>
+            <a:fillRect/>
+          </a:stretch>
+        </p:blipFill>
+        <p:spPr>
+          <a:xfrm>
+            <a:off x="0" y="0"/>
+            <a:ext cx="12192000" cy="6858000"/>
+          </a:xfrm>
+          <a:prstGeom prst="rect">
+            <a:avLst/>
+          </a:prstGeom>
+        </p:spPr>
+      </p:pic>
+    </p:spTree>
+  </p:cSld>
+  <p:clrMapOvr>
+    <a:masterClrMapping/>
+  </p:clrMapOvr>
+</p:sld>
+</file>
+
+<file path=ppt/slides/slide41.xml><?xml version="1.0" encoding="utf-8"?>
+<p:sld xmlns:a="http://schemas.openxmlformats.org/drawingml/2006/main" xmlns:p="http://schemas.openxmlformats.org/presentationml/2006/main" xmlns:r="http://schemas.openxmlformats.org/officeDocument/2006/relationships">
+  <p:cSld>
+    <p:spTree>
+      <p:nvGrpSpPr>
+        <p:cNvPr id="1" name=""/>
+        <p:cNvGrpSpPr/>
+        <p:nvPr/>
+      </p:nvGrpSpPr>
+      <p:grpSpPr/>
+      <p:pic>
+        <p:nvPicPr>
+          <p:cNvPr id="2" name="Picture 1" descr="slide-41.jpg"/>
           <p:cNvPicPr>
             <a:picLocks noChangeAspect="1"/>
           </p:cNvPicPr>

</xml_diff>

<commit_message>
Chore: site pages in plain reader language
The About panel's version history, the walkthrough decks and six blog posts
about the site told readers how it is built and checked: scripts, checks
that stop a release, data files, generators. They now say what a reader
sees or can rely on. Facts, dates, corrections and the posts' addresses are
unchanged. Komal's testing post is her own account and is left as written.

The version history heading is in sentence case, so check-about-currency.py
now finds it case-insensitively; renaming the heading away makes it fail.
The walkthrough PDF and PPTX were re-exported from the decks.

Co-Authored-By: Claude Opus 5.5 <noreply@anthropic.com>
Claude-Session: https://claude.ai/code/session_01PTZNKtij4izWQRBJPfFcs4
</commit_message>
<xml_diff>
--- a/walkthrough/JanVayu_Full_Walkthrough.pptx
+++ b/walkthrough/JanVayu_Full_Walkthrough.pptx
@@ -2152,7 +2152,7 @@
           <a:lstStyle/>
           <a:p>
             <a:r>
-              <a:t>If someone asks why X and Instagram are only links: neither can be read without a paid or authenticated API, so we link to the live search rather than show a feed that is not one. Every X link on the site is checked against X’s public embed endpoint before it ships. The blog section is generated from the blog index, so publishing is enough to reach the front page. Every gallery photograph carries its own credit and source link.</a:t>
+              <a:t>If someone asks why X and Instagram are only links: neither can be read without a paid or authenticated API, so we link to the live search rather than show a feed that is not one. Every X link on the site is checked to make sure the post still exists. A new blog post reaches the front page as soon as it is published. Every gallery photograph carries its own credit and source link.</a:t>
             </a:r>
           </a:p>
         </p:txBody>
@@ -2572,7 +2572,7 @@
           <a:lstStyle/>
           <a:p>
             <a:r>
-              <a:t>This is what separates JanVayu from a marketing site, and it is worth being exact about which half is continuous and which is periodic. Continuous: every stated figure is recomputed from the underlying data whenever the site changes, a mismatch stops the release, and since September 2026 a claim the site has publicly retracted is refused too, including inside the Hindi, Bengali, Marathi and Tamil docs. Periodic: a deeper audit that re-verifies statistics against primary sources on the web, whose findings are written into dated files in docs/. That deeper audit ran weekly through July 2026 and the deck used to promise weekly; it is not on a schedule now, so the wording says periodic. The release is stopped automatically if the audit goes more than four months without running.</a:t>
+              <a:t>This is what separates JanVayu from a marketing site, and it is worth being exact about which half is continuous and which is periodic. Continuous: whenever the site changes, every stated figure is compared with the data behind it, and a figure that disagrees does not go live. Since September 2026 a claim the site has publicly retracted cannot reappear either, including in the Hindi, Bengali, Marathi and Tamil documentation. Periodic: a deeper review goes back to the primary sources on the web, and its findings are published with their date. That review ran every week through July 2026, and the deck used to say so; it has no fixed schedule now, so the wording says periodic. If it goes more than four months without running, the site stops publishing changes until it has.</a:t>
             </a:r>
           </a:p>
         </p:txBody>
@@ -2712,7 +2712,7 @@
           <a:lstStyle/>
           <a:p>
             <a:r>
-              <a:t>Two things to be careful about if asked. First, there is deliberately no trend line across the window and the build refuses to let one in: reporting grew from 10 cities in 2015 to 264 in 2024 and the stations under each city grew with it, so a fall in Poor-or-worse days cannot be separated from a change in what was measuring. Read a single year. Second, 2015 and 2026 are part years and are marked as such next to the number, because 136 bad days of 235 in 2015 against 157 of 366 in 2024 reads as a rise and is a fall. 2015–2025 is UrbanEmissions.info’s extraction, credited on the panel; 2026 is our own parse of the same PDFs, and on three 2025 dates checked city by city the two agree on all 671 city-days they share.</a:t>
+              <a:t>Two things to be careful about if asked. First, there is deliberately no trend line across the window: reporting grew from 10 cities in 2015 to 264 in 2024 and the stations under each city grew with it, so a fall in Poor-or-worse days cannot be separated from a change in what was measuring. Read a single year. Second, 2015 and 2026 are part years and are marked as such next to the number, because 136 bad days of 235 in 2015 against 157 of 366 in 2024 reads as a rise and is a fall. 2015–2025 is UrbanEmissions.info’s extraction, credited on the panel; 2026 is our own reading of the same PDFs, and on three 2025 dates checked city by city the two agree on all 671 city-days they share.</a:t>
             </a:r>
           </a:p>
         </p:txBody>

</xml_diff>

<commit_message>
Fix: drop narration of the site's own checks from reader pages (#453)
The FAQ, the voices, progress, legal and resources panels, downloads and
the walkthrough intro no longer describe audits, scripts or fact-check
logs. Every figure still names its source.

22 Python checks, `check-inline-js` and `check-translations` pass.
`build-share.py --check` fails on `blog/2026-06-10-urban-heat-island`
both with and without this change, so the failure comes from main and
not from this PR.

---
_Generated by [Claude
Code](https://claude.ai/code/session_01PTZNKtij4izWQRBJPfFcs4)_

---------

Co-authored-by: Claude <noreply@anthropic.com>
</commit_message>
<xml_diff>
--- a/walkthrough/JanVayu_Full_Walkthrough.pptx
+++ b/walkthrough/JanVayu_Full_Walkthrough.pptx
@@ -2152,7 +2152,7 @@
           <a:lstStyle/>
           <a:p>
             <a:r>
-              <a:t>If someone asks why X and Instagram are only links: neither can be read without a paid or authenticated API, so we link to the live search rather than show a feed that is not one. Every X link on the site is checked against X’s public embed endpoint before it ships. The blog section is generated from the blog index, so publishing is enough to reach the front page. Every gallery photograph carries its own credit and source link.</a:t>
+              <a:t>If someone asks why X and Instagram are only links: neither can be read without a paid or authenticated API, so we link to the live search rather than show a feed that is not one. Every X link on the site is checked to make sure the post still exists. A new blog post reaches the front page as soon as it is published. Every gallery photograph carries its own credit and source link.</a:t>
             </a:r>
           </a:p>
         </p:txBody>
@@ -2572,7 +2572,7 @@
           <a:lstStyle/>
           <a:p>
             <a:r>
-              <a:t>This is what separates JanVayu from a marketing site, and it is worth being exact about which half is continuous and which is periodic. Continuous: every stated figure is recomputed from the underlying data whenever the site changes, a mismatch stops the release, and since September 2026 a claim the site has publicly retracted is refused too, including inside the Hindi, Bengali, Marathi and Tamil docs. Periodic: a deeper audit that re-verifies statistics against primary sources on the web, whose findings are written into dated files in docs/. That deeper audit ran weekly through July 2026 and the deck used to promise weekly; it is not on a schedule now, so the wording says periodic. The release is stopped automatically if the audit goes more than four months without running.</a:t>
+              <a:t>This is what separates JanVayu from a marketing site, and it is worth being exact about which half is continuous and which is periodic. Continuous: whenever the site changes, every stated figure is compared with the data behind it, and a figure that disagrees does not go live. Since September 2026 a claim the site has publicly retracted cannot reappear either, including in the Hindi, Bengali, Marathi and Tamil documentation. Periodic: a deeper review goes back to the primary sources on the web, and its findings are published with their date. That review ran every week through July 2026, and the deck used to say so; it has no fixed schedule now, so the wording says periodic. If it goes more than four months without running, the site stops publishing changes until it has.</a:t>
             </a:r>
           </a:p>
         </p:txBody>
@@ -2712,7 +2712,7 @@
           <a:lstStyle/>
           <a:p>
             <a:r>
-              <a:t>Two things to be careful about if asked. First, there is deliberately no trend line across the window and the build refuses to let one in: reporting grew from 10 cities in 2015 to 264 in 2024 and the stations under each city grew with it, so a fall in Poor-or-worse days cannot be separated from a change in what was measuring. Read a single year. Second, 2015 and 2026 are part years and are marked as such next to the number, because 136 bad days of 235 in 2015 against 157 of 366 in 2024 reads as a rise and is a fall. 2015–2025 is UrbanEmissions.info’s extraction, credited on the panel; 2026 is our own parse of the same PDFs, and on three 2025 dates checked city by city the two agree on all 671 city-days they share.</a:t>
+              <a:t>Two things to be careful about if asked. First, there is deliberately no trend line across the window: reporting grew from 10 cities in 2015 to 264 in 2024 and the stations under each city grew with it, so a fall in Poor-or-worse days cannot be separated from a change in what was measuring. Read a single year. Second, 2015 and 2026 are part years and are marked as such next to the number, because 136 bad days of 235 in 2015 against 157 of 366 in 2024 reads as a rise and is a fall. 2015–2025 is UrbanEmissions.info’s extraction, credited on the panel; 2026 is our own reading of the same PDFs, and on three 2025 dates checked city by city the two agree on all 671 city-days they share.</a:t>
             </a:r>
           </a:p>
         </p:txBody>

</xml_diff>